<commit_message>
Benchmark-to-reality: Spider-Realistic run RL-001 (69.5% vs paper 70.9%)
Same 508 questions in original vs realistic wording on the same machine: 72.8% -> 69.5%, gap 3.3 pts
(bootstrap 95% CI [0.8, 5.9], exact McNemar p = 0.016); against the paper's SFT CodeS-1B Spider-
Realistic EX (Table 7) the difference is -1.4 pts. Abstention on the realistic wording: 86.2% answered,
76.7% correct, wrong answers 155 -> 102. Cross-check with T2-006 on the original twins: same SQL on
485/508, 72.8% vs 73.2%. Logged in the CSV and Excel run logs; added to the report, deck and poster.

Co-Authored-By: Claude Opus 5.5 <noreply@anthropic.com>
</commit_message>
<xml_diff>
--- a/docs/Review-III/QueryGenie_Review-III.pptx
+++ b/docs/Review-III/QueryGenie_Review-III.pptx
@@ -7942,7 +7942,7 @@
                     <a:p>
                       <a:r>
                         <a:rPr sz="1200" b="1"/>
-                        <a:t>EX</a:t>
+                        <a:t>EX (paper)</a:t>
                       </a:r>
                     </a:p>
                   </a:txBody>
@@ -7983,7 +7983,7 @@
                     <a:p>
                       <a:r>
                         <a:rPr sz="1200" b="0"/>
-                        <a:t>77.8%</a:t>
+                        <a:t>77.8% (77.9%)</a:t>
                       </a:r>
                     </a:p>
                   </a:txBody>
@@ -8024,7 +8024,7 @@
                     <a:p>
                       <a:r>
                         <a:rPr sz="1200" b="0"/>
-                        <a:t>TBD</a:t>
+                        <a:t>69.5% (70.9%)</a:t>
                       </a:r>
                     </a:p>
                   </a:txBody>
@@ -8037,7 +8037,7 @@
                     <a:p>
                       <a:r>
                         <a:rPr sz="1200" b="0"/>
-                        <a:t>TBD</a:t>
+                        <a:t>86.2% / 76.7%</a:t>
                       </a:r>
                     </a:p>
                   </a:txBody>

</xml_diff>